<commit_message>
feat: v3 with Matemática-V desempenho reports + clickable links
- Added 6 Matemática-V reports (tarefa/turma/matéria PDFs + JSONs)
- Desempenho slides now use Matemática-V data (richer cross-turma analysis)
- Individual slides (correção, habilidades, relatório final) keep Cálculo 1/Otávio
- New slide: Desempenho por Matéria with cross-turma comparison table
- 25 slides, 10 clickable hyperlinks, 6 embedded images
- All PDF links point to GitHub-hosted files

Co-Authored-By: Claude Opus 4.6 (1M context) <noreply@anthropic.com>
</commit_message>
<xml_diff>
--- a/NOVO_CR_Apresentacao_v3.pptx
+++ b/NOVO_CR_Apresentacao_v3.pptx
@@ -29,6 +29,7 @@
     <p:sldId id="277" r:id="rId28"/>
     <p:sldId id="278" r:id="rId29"/>
     <p:sldId id="279" r:id="rId30"/>
+    <p:sldId id="280" r:id="rId31"/>
   </p:sldIdLst>
   <p:sldSz cx="12191695" cy="6858000" type="screen4x3"/>
   <p:notesSz cx="6858000" cy="9144000"/>
@@ -7267,7 +7268,7 @@
               </a:defRPr>
             </a:pPr>
             <a:r>
-              <a:t>Entretanto, emergem dificuldades coletivas em temas que exigem maior interpretação de enunciados e aplicação de conceitos em contextos mais complexos ou menos rotineiros. A recorrência de recomendações sobre aprofundamento na leitura de problemas e atenção a detalhes sugere que, embora a base conceitual esteja bem estabelecida, há uma lacuna quando se trata de transpor o conhecimento para situaçõe</a:t>
+              <a:t>A Prova Álgebra-V revelou uma turma em **transição entre domínio operacional e formalização**. Os dados disponíveis mostram um contraste marcante: enquanto um aluno (Ana) demonstra excelência consolidada em todas as dimensões algébricas, o outro (Bruno) revela um padrão recorrente de competência conceitual mascarada por deficiências em documentação e completude de procedimentos.</a:t>
             </a:r>
           </a:p>
         </p:txBody>
@@ -7306,7 +7307,7 @@
               </a:defRPr>
             </a:pPr>
             <a:r>
-              <a:t>Implicações pedagógicas geradas pela IA:</a:t>
+              <a:t>Diagnóstico gerado pela IA:</a:t>
             </a:r>
           </a:p>
           <a:p>
@@ -7335,7 +7336,7 @@
               </a:defRPr>
             </a:pPr>
             <a:r>
-              <a:t>  1.  Reservar tempo para leitura e análise detalhada de enunciados</a:t>
+              <a:t>  Turma em transição entre domínio operacional e formalização.</a:t>
             </a:r>
           </a:p>
           <a:p>
@@ -7351,7 +7352,7 @@
               </a:defRPr>
             </a:pPr>
             <a:r>
-              <a:t>  2.  Organizar oficinas de escrita formal de provas matemáticas</a:t>
+              <a:t>  Excelência consolidada em alguns alunos vs. deficiências estruturais em outros.</a:t>
             </a:r>
           </a:p>
           <a:p>
@@ -7367,7 +7368,7 @@
               </a:defRPr>
             </a:pPr>
             <a:r>
-              <a:t>  3.  Promover correções comentadas e devolutivas rápidas</a:t>
+              <a:t>  Competência conceitual mascarada por deficiências em documentação.</a:t>
             </a:r>
           </a:p>
         </p:txBody>
@@ -7402,7 +7403,7 @@
                 <a:latin typeface="Segoe UI"/>
                 <a:hlinkClick r:id="rId2"/>
               </a:rPr>
-              <a:t>→ Ver relatório completo: 04_desempenho_tarefa.pdf</a:t>
+              <a:t>→ Ver relatório completo: Desempenho Tarefa (Matemática-V)</a:t>
             </a:r>
           </a:p>
         </p:txBody>
@@ -7507,7 +7508,7 @@
               </a:defRPr>
             </a:pPr>
             <a:r>
-              <a:t>Tudo Isso É Real</a:t>
+              <a:t>Desempenho por Matéria — Análise Cross-Turma</a:t>
             </a:r>
           </a:p>
         </p:txBody>
@@ -7563,8 +7564,51 @@
         </p:nvSpPr>
         <p:spPr>
           <a:xfrm>
-            <a:off x="731520" y="1280160"/>
-            <a:ext cx="2011680" cy="594360"/>
+            <a:off x="548640" y="1188720"/>
+            <a:ext cx="10972800" cy="2194560"/>
+          </a:xfrm>
+          <a:prstGeom prst="rect">
+            <a:avLst/>
+          </a:prstGeom>
+          <a:solidFill>
+            <a:srgbClr val="F0F2F5"/>
+          </a:solidFill>
+          <a:ln>
+            <a:noFill/>
+          </a:ln>
+        </p:spPr>
+        <p:style>
+          <a:lnRef idx="1">
+            <a:schemeClr val="accent1"/>
+          </a:lnRef>
+          <a:fillRef idx="3">
+            <a:schemeClr val="accent1"/>
+          </a:fillRef>
+          <a:effectRef idx="2">
+            <a:schemeClr val="accent1"/>
+          </a:effectRef>
+          <a:fontRef idx="minor">
+            <a:schemeClr val="lt1"/>
+          </a:fontRef>
+        </p:style>
+        <p:txBody>
+          <a:bodyPr rtlCol="0" anchor="ctr"/>
+          <a:lstStyle/>
+          <a:p>
+            <a:pPr algn="ctr"/>
+          </a:p>
+        </p:txBody>
+      </p:sp>
+      <p:sp>
+        <p:nvSpPr>
+          <p:cNvPr id="6" name="Rectangle 5"/>
+          <p:cNvSpPr/>
+          <p:nvPr/>
+        </p:nvSpPr>
+        <p:spPr>
+          <a:xfrm>
+            <a:off x="548640" y="1188720"/>
+            <a:ext cx="54864" cy="2194560"/>
           </a:xfrm>
           <a:prstGeom prst="rect">
             <a:avLst/>
@@ -7600,14 +7644,14 @@
       </p:sp>
       <p:sp>
         <p:nvSpPr>
-          <p:cNvPr id="6" name="TextBox 5"/>
+          <p:cNvPr id="7" name="TextBox 6"/>
           <p:cNvSpPr txBox="1"/>
           <p:nvPr/>
         </p:nvSpPr>
         <p:spPr>
           <a:xfrm>
-            <a:off x="731520" y="1389888"/>
-            <a:ext cx="2011680" cy="411480"/>
+            <a:off x="822960" y="1371600"/>
+            <a:ext cx="10332720" cy="1828800"/>
           </a:xfrm>
           <a:prstGeom prst="rect">
             <a:avLst/>
@@ -7620,30 +7664,94 @@
           </a:bodyPr>
           <a:lstStyle/>
           <a:p>
-            <a:pPr algn="ctr">
+            <a:pPr>
+              <a:spcAft>
+                <a:spcPts val="840"/>
+              </a:spcAft>
               <a:defRPr sz="1400" b="1">
                 <a:solidFill>
-                  <a:srgbClr val="FFFFFF"/>
-                </a:solidFill>
-                <a:latin typeface="Segoe UI"/>
-              </a:defRPr>
-            </a:pPr>
-            <a:r>
-              <a:t>Questão</a:t>
-            </a:r>
-          </a:p>
-        </p:txBody>
-      </p:sp>
-      <p:sp>
-        <p:nvSpPr>
-          <p:cNvPr id="7" name="TextBox 6"/>
+                  <a:srgbClr val="0056A0"/>
+                </a:solidFill>
+                <a:latin typeface="Segoe UI"/>
+              </a:defRPr>
+            </a:pPr>
+            <a:r>
+              <a:t>Trecho real — Síntese Cross-Turma (Matemática-V):</a:t>
+            </a:r>
+          </a:p>
+          <a:p>
+            <a:pPr>
+              <a:spcAft>
+                <a:spcPts val="840"/>
+              </a:spcAft>
+              <a:defRPr sz="1400" b="0">
+                <a:solidFill>
+                  <a:srgbClr val="333333"/>
+                </a:solidFill>
+                <a:latin typeface="Segoe UI"/>
+              </a:defRPr>
+            </a:pPr>
+          </a:p>
+          <a:p>
+            <a:pPr>
+              <a:spcAft>
+                <a:spcPts val="840"/>
+              </a:spcAft>
+              <a:defRPr sz="1400" b="0">
+                <a:solidFill>
+                  <a:srgbClr val="333333"/>
+                </a:solidFill>
+                <a:latin typeface="Segoe UI"/>
+              </a:defRPr>
+            </a:pPr>
+            <a:r>
+              <a:t>Matemática-V apresenta um quadro misto e polarizado. O aprendizado não é</a:t>
+            </a:r>
+          </a:p>
+          <a:p>
+            <a:pPr>
+              <a:spcAft>
+                <a:spcPts val="840"/>
+              </a:spcAft>
+              <a:defRPr sz="1400" b="0">
+                <a:solidFill>
+                  <a:srgbClr val="333333"/>
+                </a:solidFill>
+                <a:latin typeface="Segoe UI"/>
+              </a:defRPr>
+            </a:pPr>
+            <a:r>
+              <a:t>uniforme: há alunos com domínio excepcional, mas também alunos com deficiências</a:t>
+            </a:r>
+          </a:p>
+          <a:p>
+            <a:pPr>
+              <a:spcAft>
+                <a:spcPts val="840"/>
+              </a:spcAft>
+              <a:defRPr sz="1400" b="0">
+                <a:solidFill>
+                  <a:srgbClr val="333333"/>
+                </a:solidFill>
+                <a:latin typeface="Segoe UI"/>
+              </a:defRPr>
+            </a:pPr>
+            <a:r>
+              <a:t>estruturais significativas.</a:t>
+            </a:r>
+          </a:p>
+        </p:txBody>
+      </p:sp>
+      <p:sp>
+        <p:nvSpPr>
+          <p:cNvPr id="8" name="TextBox 7"/>
           <p:cNvSpPr txBox="1"/>
           <p:nvPr/>
         </p:nvSpPr>
         <p:spPr>
           <a:xfrm>
-            <a:off x="2926080" y="1325880"/>
-            <a:ext cx="3200400" cy="548640"/>
+            <a:off x="731520" y="3657600"/>
+            <a:ext cx="10515600" cy="2011680"/>
           </a:xfrm>
           <a:prstGeom prst="rect">
             <a:avLst/>
@@ -7656,8 +7764,85 @@
           </a:bodyPr>
           <a:lstStyle/>
           <a:p>
-            <a:pPr algn="l">
-              <a:defRPr sz="1600" b="1">
+            <a:pPr>
+              <a:spcAft>
+                <a:spcPts val="840"/>
+              </a:spcAft>
+              <a:defRPr sz="1400" b="1">
+                <a:solidFill>
+                  <a:srgbClr val="0056A0"/>
+                </a:solidFill>
+                <a:latin typeface="Segoe UI"/>
+              </a:defRPr>
+            </a:pPr>
+            <a:r>
+              <a:t>Comparação entre turmas (gerada automaticamente):</a:t>
+            </a:r>
+          </a:p>
+          <a:p>
+            <a:pPr>
+              <a:spcAft>
+                <a:spcPts val="840"/>
+              </a:spcAft>
+              <a:defRPr sz="1400" b="0">
+                <a:solidFill>
+                  <a:srgbClr val="333333"/>
+                </a:solidFill>
+                <a:latin typeface="Segoe UI"/>
+              </a:defRPr>
+            </a:pPr>
+          </a:p>
+          <a:p>
+            <a:pPr>
+              <a:spcAft>
+                <a:spcPts val="840"/>
+              </a:spcAft>
+              <a:defRPr sz="1400" b="0">
+                <a:solidFill>
+                  <a:srgbClr val="333333"/>
+                </a:solidFill>
+                <a:latin typeface="Segoe UI"/>
+              </a:defRPr>
+            </a:pPr>
+            <a:r>
+              <a:t>Alpha-V:  Média Álgebra 6.63  |  Média Geometria 6.88  |  Polarizado</a:t>
+            </a:r>
+          </a:p>
+          <a:p>
+            <a:pPr>
+              <a:spcAft>
+                <a:spcPts val="840"/>
+              </a:spcAft>
+              <a:defRPr sz="1400" b="0">
+                <a:solidFill>
+                  <a:srgbClr val="333333"/>
+                </a:solidFill>
+                <a:latin typeface="Segoe UI"/>
+              </a:defRPr>
+            </a:pPr>
+            <a:r>
+              <a:t>Beta-V:   Média Álgebra ~5.6   |  Média Geometria ~5.95  |  Intermediário</a:t>
+            </a:r>
+          </a:p>
+          <a:p>
+            <a:pPr>
+              <a:spcAft>
+                <a:spcPts val="840"/>
+              </a:spcAft>
+              <a:defRPr sz="1400" b="0">
+                <a:solidFill>
+                  <a:srgbClr val="333333"/>
+                </a:solidFill>
+                <a:latin typeface="Segoe UI"/>
+              </a:defRPr>
+            </a:pPr>
+          </a:p>
+          <a:p>
+            <a:pPr>
+              <a:spcAft>
+                <a:spcPts val="840"/>
+              </a:spcAft>
+              <a:defRPr sz="1400" b="1">
                 <a:solidFill>
                   <a:srgbClr val="002B5C"/>
                 </a:solidFill>
@@ -7665,21 +7850,37 @@
               </a:defRPr>
             </a:pPr>
             <a:r>
-              <a:t>Correção</a:t>
-            </a:r>
-          </a:p>
-        </p:txBody>
-      </p:sp>
-      <p:sp>
-        <p:nvSpPr>
-          <p:cNvPr id="8" name="TextBox 7"/>
+              <a:t>Diagnóstico: não é um problema de capacidade cognitiva geral, mas de lacunas</a:t>
+            </a:r>
+          </a:p>
+          <a:p>
+            <a:pPr>
+              <a:spcAft>
+                <a:spcPts val="840"/>
+              </a:spcAft>
+              <a:defRPr sz="1400" b="1">
+                <a:solidFill>
+                  <a:srgbClr val="002B5C"/>
+                </a:solidFill>
+                <a:latin typeface="Segoe UI"/>
+              </a:defRPr>
+            </a:pPr>
+            <a:r>
+              <a:t>específicas, falta de metodologia, e deficiências em comunicação matemática.</a:t>
+            </a:r>
+          </a:p>
+        </p:txBody>
+      </p:sp>
+      <p:sp>
+        <p:nvSpPr>
+          <p:cNvPr id="9" name="TextBox 8"/>
           <p:cNvSpPr txBox="1"/>
           <p:nvPr/>
         </p:nvSpPr>
         <p:spPr>
           <a:xfrm>
-            <a:off x="6217920" y="1325880"/>
-            <a:ext cx="3657600" cy="548640"/>
+            <a:off x="731520" y="5943600"/>
+            <a:ext cx="7315200" cy="365760"/>
           </a:xfrm>
           <a:prstGeom prst="rect">
             <a:avLst/>
@@ -7692,1017 +7893,15 @@
           </a:bodyPr>
           <a:lstStyle/>
           <a:p>
-            <a:pPr algn="l">
-              <a:defRPr sz="1400" b="0">
-                <a:solidFill>
-                  <a:srgbClr val="666666"/>
-                </a:solidFill>
-                <a:latin typeface="Segoe UI"/>
-              </a:defRPr>
-            </a:pPr>
-            <a:r>
-              <a:t>Raciocínio, tipo de erro, potencial</a:t>
-            </a:r>
-          </a:p>
-        </p:txBody>
-      </p:sp>
-      <p:sp>
-        <p:nvSpPr>
-          <p:cNvPr id="9" name="TextBox 8"/>
-          <p:cNvSpPr txBox="1"/>
-          <p:nvPr/>
-        </p:nvSpPr>
-        <p:spPr>
-          <a:xfrm>
-            <a:off x="10058400" y="1325880"/>
-            <a:ext cx="1828800" cy="548640"/>
-          </a:xfrm>
-          <a:prstGeom prst="rect">
-            <a:avLst/>
-          </a:prstGeom>
-          <a:noFill/>
-        </p:spPr>
-        <p:txBody>
-          <a:bodyPr wrap="square">
-            <a:spAutoFit/>
-          </a:bodyPr>
-          <a:lstStyle/>
-          <a:p>
-            <a:r>
-              <a:rPr sz="1100" u="sng">
+            <a:r>
+              <a:rPr sz="1400" u="sng">
                 <a:solidFill>
                   <a:srgbClr val="4A90D9"/>
                 </a:solidFill>
                 <a:latin typeface="Segoe UI"/>
                 <a:hlinkClick r:id="rId2"/>
               </a:rPr>
-              <a:t>📎 Abrir PDF</a:t>
-            </a:r>
-          </a:p>
-        </p:txBody>
-      </p:sp>
-      <p:sp>
-        <p:nvSpPr>
-          <p:cNvPr id="10" name="Rectangle 9"/>
-          <p:cNvSpPr/>
-          <p:nvPr/>
-        </p:nvSpPr>
-        <p:spPr>
-          <a:xfrm>
-            <a:off x="731520" y="2057400"/>
-            <a:ext cx="2011680" cy="594360"/>
-          </a:xfrm>
-          <a:prstGeom prst="rect">
-            <a:avLst/>
-          </a:prstGeom>
-          <a:solidFill>
-            <a:srgbClr val="0056A0"/>
-          </a:solidFill>
-          <a:ln>
-            <a:noFill/>
-          </a:ln>
-        </p:spPr>
-        <p:style>
-          <a:lnRef idx="1">
-            <a:schemeClr val="accent1"/>
-          </a:lnRef>
-          <a:fillRef idx="3">
-            <a:schemeClr val="accent1"/>
-          </a:fillRef>
-          <a:effectRef idx="2">
-            <a:schemeClr val="accent1"/>
-          </a:effectRef>
-          <a:fontRef idx="minor">
-            <a:schemeClr val="lt1"/>
-          </a:fontRef>
-        </p:style>
-        <p:txBody>
-          <a:bodyPr rtlCol="0" anchor="ctr"/>
-          <a:lstStyle/>
-          <a:p>
-            <a:pPr algn="ctr"/>
-          </a:p>
-        </p:txBody>
-      </p:sp>
-      <p:sp>
-        <p:nvSpPr>
-          <p:cNvPr id="11" name="TextBox 10"/>
-          <p:cNvSpPr txBox="1"/>
-          <p:nvPr/>
-        </p:nvSpPr>
-        <p:spPr>
-          <a:xfrm>
-            <a:off x="731520" y="2167128"/>
-            <a:ext cx="2011680" cy="411480"/>
-          </a:xfrm>
-          <a:prstGeom prst="rect">
-            <a:avLst/>
-          </a:prstGeom>
-          <a:noFill/>
-        </p:spPr>
-        <p:txBody>
-          <a:bodyPr wrap="square">
-            <a:spAutoFit/>
-          </a:bodyPr>
-          <a:lstStyle/>
-          <a:p>
-            <a:pPr algn="ctr">
-              <a:defRPr sz="1400" b="1">
-                <a:solidFill>
-                  <a:srgbClr val="FFFFFF"/>
-                </a:solidFill>
-                <a:latin typeface="Segoe UI"/>
-              </a:defRPr>
-            </a:pPr>
-            <a:r>
-              <a:t>Aluno</a:t>
-            </a:r>
-          </a:p>
-        </p:txBody>
-      </p:sp>
-      <p:sp>
-        <p:nvSpPr>
-          <p:cNvPr id="12" name="TextBox 11"/>
-          <p:cNvSpPr txBox="1"/>
-          <p:nvPr/>
-        </p:nvSpPr>
-        <p:spPr>
-          <a:xfrm>
-            <a:off x="2926080" y="2103120"/>
-            <a:ext cx="3200400" cy="548640"/>
-          </a:xfrm>
-          <a:prstGeom prst="rect">
-            <a:avLst/>
-          </a:prstGeom>
-          <a:noFill/>
-        </p:spPr>
-        <p:txBody>
-          <a:bodyPr wrap="square">
-            <a:spAutoFit/>
-          </a:bodyPr>
-          <a:lstStyle/>
-          <a:p>
-            <a:pPr algn="l">
-              <a:defRPr sz="1600" b="1">
-                <a:solidFill>
-                  <a:srgbClr val="002B5C"/>
-                </a:solidFill>
-                <a:latin typeface="Segoe UI"/>
-              </a:defRPr>
-            </a:pPr>
-            <a:r>
-              <a:t>Análise de Habilidades</a:t>
-            </a:r>
-          </a:p>
-        </p:txBody>
-      </p:sp>
-      <p:sp>
-        <p:nvSpPr>
-          <p:cNvPr id="13" name="TextBox 12"/>
-          <p:cNvSpPr txBox="1"/>
-          <p:nvPr/>
-        </p:nvSpPr>
-        <p:spPr>
-          <a:xfrm>
-            <a:off x="6217920" y="2103120"/>
-            <a:ext cx="3657600" cy="548640"/>
-          </a:xfrm>
-          <a:prstGeom prst="rect">
-            <a:avLst/>
-          </a:prstGeom>
-          <a:noFill/>
-        </p:spPr>
-        <p:txBody>
-          <a:bodyPr wrap="square">
-            <a:spAutoFit/>
-          </a:bodyPr>
-          <a:lstStyle/>
-          <a:p>
-            <a:pPr algn="l">
-              <a:defRPr sz="1400" b="0">
-                <a:solidFill>
-                  <a:srgbClr val="666666"/>
-                </a:solidFill>
-                <a:latin typeface="Segoe UI"/>
-              </a:defRPr>
-            </a:pPr>
-            <a:r>
-              <a:t>Perfil cognitivo, padrões, recomendações</a:t>
-            </a:r>
-          </a:p>
-        </p:txBody>
-      </p:sp>
-      <p:sp>
-        <p:nvSpPr>
-          <p:cNvPr id="14" name="TextBox 13"/>
-          <p:cNvSpPr txBox="1"/>
-          <p:nvPr/>
-        </p:nvSpPr>
-        <p:spPr>
-          <a:xfrm>
-            <a:off x="10058400" y="2103120"/>
-            <a:ext cx="1828800" cy="548640"/>
-          </a:xfrm>
-          <a:prstGeom prst="rect">
-            <a:avLst/>
-          </a:prstGeom>
-          <a:noFill/>
-        </p:spPr>
-        <p:txBody>
-          <a:bodyPr wrap="square">
-            <a:spAutoFit/>
-          </a:bodyPr>
-          <a:lstStyle/>
-          <a:p>
-            <a:r>
-              <a:rPr sz="1100" u="sng">
-                <a:solidFill>
-                  <a:srgbClr val="4A90D9"/>
-                </a:solidFill>
-                <a:latin typeface="Segoe UI"/>
-                <a:hlinkClick r:id="rId3"/>
-              </a:rPr>
-              <a:t>📎 Abrir PDF</a:t>
-            </a:r>
-          </a:p>
-        </p:txBody>
-      </p:sp>
-      <p:sp>
-        <p:nvSpPr>
-          <p:cNvPr id="15" name="Rectangle 14"/>
-          <p:cNvSpPr/>
-          <p:nvPr/>
-        </p:nvSpPr>
-        <p:spPr>
-          <a:xfrm>
-            <a:off x="731520" y="2834640"/>
-            <a:ext cx="2011680" cy="594360"/>
-          </a:xfrm>
-          <a:prstGeom prst="rect">
-            <a:avLst/>
-          </a:prstGeom>
-          <a:solidFill>
-            <a:srgbClr val="0056A0"/>
-          </a:solidFill>
-          <a:ln>
-            <a:noFill/>
-          </a:ln>
-        </p:spPr>
-        <p:style>
-          <a:lnRef idx="1">
-            <a:schemeClr val="accent1"/>
-          </a:lnRef>
-          <a:fillRef idx="3">
-            <a:schemeClr val="accent1"/>
-          </a:fillRef>
-          <a:effectRef idx="2">
-            <a:schemeClr val="accent1"/>
-          </a:effectRef>
-          <a:fontRef idx="minor">
-            <a:schemeClr val="lt1"/>
-          </a:fontRef>
-        </p:style>
-        <p:txBody>
-          <a:bodyPr rtlCol="0" anchor="ctr"/>
-          <a:lstStyle/>
-          <a:p>
-            <a:pPr algn="ctr"/>
-          </a:p>
-        </p:txBody>
-      </p:sp>
-      <p:sp>
-        <p:nvSpPr>
-          <p:cNvPr id="16" name="TextBox 15"/>
-          <p:cNvSpPr txBox="1"/>
-          <p:nvPr/>
-        </p:nvSpPr>
-        <p:spPr>
-          <a:xfrm>
-            <a:off x="731520" y="2944368"/>
-            <a:ext cx="2011680" cy="411480"/>
-          </a:xfrm>
-          <a:prstGeom prst="rect">
-            <a:avLst/>
-          </a:prstGeom>
-          <a:noFill/>
-        </p:spPr>
-        <p:txBody>
-          <a:bodyPr wrap="square">
-            <a:spAutoFit/>
-          </a:bodyPr>
-          <a:lstStyle/>
-          <a:p>
-            <a:pPr algn="ctr">
-              <a:defRPr sz="1400" b="1">
-                <a:solidFill>
-                  <a:srgbClr val="FFFFFF"/>
-                </a:solidFill>
-                <a:latin typeface="Segoe UI"/>
-              </a:defRPr>
-            </a:pPr>
-            <a:r>
-              <a:t>Aluno</a:t>
-            </a:r>
-          </a:p>
-        </p:txBody>
-      </p:sp>
-      <p:sp>
-        <p:nvSpPr>
-          <p:cNvPr id="17" name="TextBox 16"/>
-          <p:cNvSpPr txBox="1"/>
-          <p:nvPr/>
-        </p:nvSpPr>
-        <p:spPr>
-          <a:xfrm>
-            <a:off x="2926080" y="2880360"/>
-            <a:ext cx="3200400" cy="548640"/>
-          </a:xfrm>
-          <a:prstGeom prst="rect">
-            <a:avLst/>
-          </a:prstGeom>
-          <a:noFill/>
-        </p:spPr>
-        <p:txBody>
-          <a:bodyPr wrap="square">
-            <a:spAutoFit/>
-          </a:bodyPr>
-          <a:lstStyle/>
-          <a:p>
-            <a:pPr algn="l">
-              <a:defRPr sz="1600" b="1">
-                <a:solidFill>
-                  <a:srgbClr val="002B5C"/>
-                </a:solidFill>
-                <a:latin typeface="Segoe UI"/>
-              </a:defRPr>
-            </a:pPr>
-            <a:r>
-              <a:t>Relatório Final</a:t>
-            </a:r>
-          </a:p>
-        </p:txBody>
-      </p:sp>
-      <p:sp>
-        <p:nvSpPr>
-          <p:cNvPr id="18" name="TextBox 17"/>
-          <p:cNvSpPr txBox="1"/>
-          <p:nvPr/>
-        </p:nvSpPr>
-        <p:spPr>
-          <a:xfrm>
-            <a:off x="6217920" y="2880360"/>
-            <a:ext cx="3657600" cy="548640"/>
-          </a:xfrm>
-          <a:prstGeom prst="rect">
-            <a:avLst/>
-          </a:prstGeom>
-          <a:noFill/>
-        </p:spPr>
-        <p:txBody>
-          <a:bodyPr wrap="square">
-            <a:spAutoFit/>
-          </a:bodyPr>
-          <a:lstStyle/>
-          <a:p>
-            <a:pPr algn="l">
-              <a:defRPr sz="1400" b="0">
-                <a:solidFill>
-                  <a:srgbClr val="666666"/>
-                </a:solidFill>
-                <a:latin typeface="Segoe UI"/>
-              </a:defRPr>
-            </a:pPr>
-            <a:r>
-              <a:t>Narrativa completa para aluno e pais</a:t>
-            </a:r>
-          </a:p>
-        </p:txBody>
-      </p:sp>
-      <p:sp>
-        <p:nvSpPr>
-          <p:cNvPr id="19" name="TextBox 18"/>
-          <p:cNvSpPr txBox="1"/>
-          <p:nvPr/>
-        </p:nvSpPr>
-        <p:spPr>
-          <a:xfrm>
-            <a:off x="10058400" y="2880360"/>
-            <a:ext cx="1828800" cy="548640"/>
-          </a:xfrm>
-          <a:prstGeom prst="rect">
-            <a:avLst/>
-          </a:prstGeom>
-          <a:noFill/>
-        </p:spPr>
-        <p:txBody>
-          <a:bodyPr wrap="square">
-            <a:spAutoFit/>
-          </a:bodyPr>
-          <a:lstStyle/>
-          <a:p>
-            <a:r>
-              <a:rPr sz="1100" u="sng">
-                <a:solidFill>
-                  <a:srgbClr val="4A90D9"/>
-                </a:solidFill>
-                <a:latin typeface="Segoe UI"/>
-                <a:hlinkClick r:id="rId4"/>
-              </a:rPr>
-              <a:t>📎 Abrir PDF</a:t>
-            </a:r>
-          </a:p>
-        </p:txBody>
-      </p:sp>
-      <p:sp>
-        <p:nvSpPr>
-          <p:cNvPr id="20" name="Rectangle 19"/>
-          <p:cNvSpPr/>
-          <p:nvPr/>
-        </p:nvSpPr>
-        <p:spPr>
-          <a:xfrm>
-            <a:off x="731520" y="3611880"/>
-            <a:ext cx="2011680" cy="594360"/>
-          </a:xfrm>
-          <a:prstGeom prst="rect">
-            <a:avLst/>
-          </a:prstGeom>
-          <a:solidFill>
-            <a:srgbClr val="002B5C"/>
-          </a:solidFill>
-          <a:ln>
-            <a:noFill/>
-          </a:ln>
-        </p:spPr>
-        <p:style>
-          <a:lnRef idx="1">
-            <a:schemeClr val="accent1"/>
-          </a:lnRef>
-          <a:fillRef idx="3">
-            <a:schemeClr val="accent1"/>
-          </a:fillRef>
-          <a:effectRef idx="2">
-            <a:schemeClr val="accent1"/>
-          </a:effectRef>
-          <a:fontRef idx="minor">
-            <a:schemeClr val="lt1"/>
-          </a:fontRef>
-        </p:style>
-        <p:txBody>
-          <a:bodyPr rtlCol="0" anchor="ctr"/>
-          <a:lstStyle/>
-          <a:p>
-            <a:pPr algn="ctr"/>
-          </a:p>
-        </p:txBody>
-      </p:sp>
-      <p:sp>
-        <p:nvSpPr>
-          <p:cNvPr id="21" name="TextBox 20"/>
-          <p:cNvSpPr txBox="1"/>
-          <p:nvPr/>
-        </p:nvSpPr>
-        <p:spPr>
-          <a:xfrm>
-            <a:off x="731520" y="3721608"/>
-            <a:ext cx="2011680" cy="411480"/>
-          </a:xfrm>
-          <a:prstGeom prst="rect">
-            <a:avLst/>
-          </a:prstGeom>
-          <a:noFill/>
-        </p:spPr>
-        <p:txBody>
-          <a:bodyPr wrap="square">
-            <a:spAutoFit/>
-          </a:bodyPr>
-          <a:lstStyle/>
-          <a:p>
-            <a:pPr algn="ctr">
-              <a:defRPr sz="1400" b="1">
-                <a:solidFill>
-                  <a:srgbClr val="FFFFFF"/>
-                </a:solidFill>
-                <a:latin typeface="Segoe UI"/>
-              </a:defRPr>
-            </a:pPr>
-            <a:r>
-              <a:t>Turma × Atividade</a:t>
-            </a:r>
-          </a:p>
-        </p:txBody>
-      </p:sp>
-      <p:sp>
-        <p:nvSpPr>
-          <p:cNvPr id="22" name="TextBox 21"/>
-          <p:cNvSpPr txBox="1"/>
-          <p:nvPr/>
-        </p:nvSpPr>
-        <p:spPr>
-          <a:xfrm>
-            <a:off x="2926080" y="3657600"/>
-            <a:ext cx="3200400" cy="548640"/>
-          </a:xfrm>
-          <a:prstGeom prst="rect">
-            <a:avLst/>
-          </a:prstGeom>
-          <a:noFill/>
-        </p:spPr>
-        <p:txBody>
-          <a:bodyPr wrap="square">
-            <a:spAutoFit/>
-          </a:bodyPr>
-          <a:lstStyle/>
-          <a:p>
-            <a:pPr algn="l">
-              <a:defRPr sz="1600" b="1">
-                <a:solidFill>
-                  <a:srgbClr val="002B5C"/>
-                </a:solidFill>
-                <a:latin typeface="Segoe UI"/>
-              </a:defRPr>
-            </a:pPr>
-            <a:r>
-              <a:t>Desempenho Tarefa</a:t>
-            </a:r>
-          </a:p>
-        </p:txBody>
-      </p:sp>
-      <p:sp>
-        <p:nvSpPr>
-          <p:cNvPr id="23" name="TextBox 22"/>
-          <p:cNvSpPr txBox="1"/>
-          <p:nvPr/>
-        </p:nvSpPr>
-        <p:spPr>
-          <a:xfrm>
-            <a:off x="6217920" y="3657600"/>
-            <a:ext cx="3657600" cy="548640"/>
-          </a:xfrm>
-          <a:prstGeom prst="rect">
-            <a:avLst/>
-          </a:prstGeom>
-          <a:noFill/>
-        </p:spPr>
-        <p:txBody>
-          <a:bodyPr wrap="square">
-            <a:spAutoFit/>
-          </a:bodyPr>
-          <a:lstStyle/>
-          <a:p>
-            <a:pPr algn="l">
-              <a:defRPr sz="1400" b="0">
-                <a:solidFill>
-                  <a:srgbClr val="666666"/>
-                </a:solidFill>
-                <a:latin typeface="Segoe UI"/>
-              </a:defRPr>
-            </a:pPr>
-            <a:r>
-              <a:t>Padrões coletivos, exemplos específicos</a:t>
-            </a:r>
-          </a:p>
-        </p:txBody>
-      </p:sp>
-      <p:sp>
-        <p:nvSpPr>
-          <p:cNvPr id="24" name="TextBox 23"/>
-          <p:cNvSpPr txBox="1"/>
-          <p:nvPr/>
-        </p:nvSpPr>
-        <p:spPr>
-          <a:xfrm>
-            <a:off x="10058400" y="3657600"/>
-            <a:ext cx="1828800" cy="548640"/>
-          </a:xfrm>
-          <a:prstGeom prst="rect">
-            <a:avLst/>
-          </a:prstGeom>
-          <a:noFill/>
-        </p:spPr>
-        <p:txBody>
-          <a:bodyPr wrap="square">
-            <a:spAutoFit/>
-          </a:bodyPr>
-          <a:lstStyle/>
-          <a:p>
-            <a:r>
-              <a:rPr sz="1100" u="sng">
-                <a:solidFill>
-                  <a:srgbClr val="4A90D9"/>
-                </a:solidFill>
-                <a:latin typeface="Segoe UI"/>
-                <a:hlinkClick r:id="rId5"/>
-              </a:rPr>
-              <a:t>📎 Abrir PDF</a:t>
-            </a:r>
-          </a:p>
-        </p:txBody>
-      </p:sp>
-      <p:sp>
-        <p:nvSpPr>
-          <p:cNvPr id="25" name="Rectangle 24"/>
-          <p:cNvSpPr/>
-          <p:nvPr/>
-        </p:nvSpPr>
-        <p:spPr>
-          <a:xfrm>
-            <a:off x="731520" y="4389120"/>
-            <a:ext cx="2011680" cy="594360"/>
-          </a:xfrm>
-          <a:prstGeom prst="rect">
-            <a:avLst/>
-          </a:prstGeom>
-          <a:solidFill>
-            <a:srgbClr val="002B5C"/>
-          </a:solidFill>
-          <a:ln>
-            <a:noFill/>
-          </a:ln>
-        </p:spPr>
-        <p:style>
-          <a:lnRef idx="1">
-            <a:schemeClr val="accent1"/>
-          </a:lnRef>
-          <a:fillRef idx="3">
-            <a:schemeClr val="accent1"/>
-          </a:fillRef>
-          <a:effectRef idx="2">
-            <a:schemeClr val="accent1"/>
-          </a:effectRef>
-          <a:fontRef idx="minor">
-            <a:schemeClr val="lt1"/>
-          </a:fontRef>
-        </p:style>
-        <p:txBody>
-          <a:bodyPr rtlCol="0" anchor="ctr"/>
-          <a:lstStyle/>
-          <a:p>
-            <a:pPr algn="ctr"/>
-          </a:p>
-        </p:txBody>
-      </p:sp>
-      <p:sp>
-        <p:nvSpPr>
-          <p:cNvPr id="26" name="TextBox 25"/>
-          <p:cNvSpPr txBox="1"/>
-          <p:nvPr/>
-        </p:nvSpPr>
-        <p:spPr>
-          <a:xfrm>
-            <a:off x="731520" y="4498848"/>
-            <a:ext cx="2011680" cy="411480"/>
-          </a:xfrm>
-          <a:prstGeom prst="rect">
-            <a:avLst/>
-          </a:prstGeom>
-          <a:noFill/>
-        </p:spPr>
-        <p:txBody>
-          <a:bodyPr wrap="square">
-            <a:spAutoFit/>
-          </a:bodyPr>
-          <a:lstStyle/>
-          <a:p>
-            <a:pPr algn="ctr">
-              <a:defRPr sz="1400" b="1">
-                <a:solidFill>
-                  <a:srgbClr val="FFFFFF"/>
-                </a:solidFill>
-                <a:latin typeface="Segoe UI"/>
-              </a:defRPr>
-            </a:pPr>
-            <a:r>
-              <a:t>Turma</a:t>
-            </a:r>
-          </a:p>
-        </p:txBody>
-      </p:sp>
-      <p:sp>
-        <p:nvSpPr>
-          <p:cNvPr id="27" name="TextBox 26"/>
-          <p:cNvSpPr txBox="1"/>
-          <p:nvPr/>
-        </p:nvSpPr>
-        <p:spPr>
-          <a:xfrm>
-            <a:off x="2926080" y="4434840"/>
-            <a:ext cx="3200400" cy="548640"/>
-          </a:xfrm>
-          <a:prstGeom prst="rect">
-            <a:avLst/>
-          </a:prstGeom>
-          <a:noFill/>
-        </p:spPr>
-        <p:txBody>
-          <a:bodyPr wrap="square">
-            <a:spAutoFit/>
-          </a:bodyPr>
-          <a:lstStyle/>
-          <a:p>
-            <a:pPr algn="l">
-              <a:defRPr sz="1600" b="1">
-                <a:solidFill>
-                  <a:srgbClr val="002B5C"/>
-                </a:solidFill>
-                <a:latin typeface="Segoe UI"/>
-              </a:defRPr>
-            </a:pPr>
-            <a:r>
-              <a:t>Desempenho Turma</a:t>
-            </a:r>
-          </a:p>
-        </p:txBody>
-      </p:sp>
-      <p:sp>
-        <p:nvSpPr>
-          <p:cNvPr id="28" name="TextBox 27"/>
-          <p:cNvSpPr txBox="1"/>
-          <p:nvPr/>
-        </p:nvSpPr>
-        <p:spPr>
-          <a:xfrm>
-            <a:off x="6217920" y="4434840"/>
-            <a:ext cx="3657600" cy="548640"/>
-          </a:xfrm>
-          <a:prstGeom prst="rect">
-            <a:avLst/>
-          </a:prstGeom>
-          <a:noFill/>
-        </p:spPr>
-        <p:txBody>
-          <a:bodyPr wrap="square">
-            <a:spAutoFit/>
-          </a:bodyPr>
-          <a:lstStyle/>
-          <a:p>
-            <a:pPr algn="l">
-              <a:defRPr sz="1400" b="0">
-                <a:solidFill>
-                  <a:srgbClr val="666666"/>
-                </a:solidFill>
-                <a:latin typeface="Segoe UI"/>
-              </a:defRPr>
-            </a:pPr>
-            <a:r>
-              <a:t>Evolução ao longo do tempo</a:t>
-            </a:r>
-          </a:p>
-        </p:txBody>
-      </p:sp>
-      <p:sp>
-        <p:nvSpPr>
-          <p:cNvPr id="29" name="TextBox 28"/>
-          <p:cNvSpPr txBox="1"/>
-          <p:nvPr/>
-        </p:nvSpPr>
-        <p:spPr>
-          <a:xfrm>
-            <a:off x="10058400" y="4434840"/>
-            <a:ext cx="1828800" cy="548640"/>
-          </a:xfrm>
-          <a:prstGeom prst="rect">
-            <a:avLst/>
-          </a:prstGeom>
-          <a:noFill/>
-        </p:spPr>
-        <p:txBody>
-          <a:bodyPr wrap="square">
-            <a:spAutoFit/>
-          </a:bodyPr>
-          <a:lstStyle/>
-          <a:p>
-            <a:r>
-              <a:rPr sz="1100" u="sng">
-                <a:solidFill>
-                  <a:srgbClr val="4A90D9"/>
-                </a:solidFill>
-                <a:latin typeface="Segoe UI"/>
-                <a:hlinkClick r:id="rId6"/>
-              </a:rPr>
-              <a:t>📎 Abrir PDF</a:t>
-            </a:r>
-          </a:p>
-        </p:txBody>
-      </p:sp>
-      <p:sp>
-        <p:nvSpPr>
-          <p:cNvPr id="30" name="Rectangle 29"/>
-          <p:cNvSpPr/>
-          <p:nvPr/>
-        </p:nvSpPr>
-        <p:spPr>
-          <a:xfrm>
-            <a:off x="731520" y="5166360"/>
-            <a:ext cx="2011680" cy="594360"/>
-          </a:xfrm>
-          <a:prstGeom prst="rect">
-            <a:avLst/>
-          </a:prstGeom>
-          <a:solidFill>
-            <a:srgbClr val="002B5C"/>
-          </a:solidFill>
-          <a:ln>
-            <a:noFill/>
-          </a:ln>
-        </p:spPr>
-        <p:style>
-          <a:lnRef idx="1">
-            <a:schemeClr val="accent1"/>
-          </a:lnRef>
-          <a:fillRef idx="3">
-            <a:schemeClr val="accent1"/>
-          </a:fillRef>
-          <a:effectRef idx="2">
-            <a:schemeClr val="accent1"/>
-          </a:effectRef>
-          <a:fontRef idx="minor">
-            <a:schemeClr val="lt1"/>
-          </a:fontRef>
-        </p:style>
-        <p:txBody>
-          <a:bodyPr rtlCol="0" anchor="ctr"/>
-          <a:lstStyle/>
-          <a:p>
-            <a:pPr algn="ctr"/>
-          </a:p>
-        </p:txBody>
-      </p:sp>
-      <p:sp>
-        <p:nvSpPr>
-          <p:cNvPr id="31" name="TextBox 30"/>
-          <p:cNvSpPr txBox="1"/>
-          <p:nvPr/>
-        </p:nvSpPr>
-        <p:spPr>
-          <a:xfrm>
-            <a:off x="731520" y="5276088"/>
-            <a:ext cx="2011680" cy="411480"/>
-          </a:xfrm>
-          <a:prstGeom prst="rect">
-            <a:avLst/>
-          </a:prstGeom>
-          <a:noFill/>
-        </p:spPr>
-        <p:txBody>
-          <a:bodyPr wrap="square">
-            <a:spAutoFit/>
-          </a:bodyPr>
-          <a:lstStyle/>
-          <a:p>
-            <a:pPr algn="ctr">
-              <a:defRPr sz="1400" b="1">
-                <a:solidFill>
-                  <a:srgbClr val="FFFFFF"/>
-                </a:solidFill>
-                <a:latin typeface="Segoe UI"/>
-              </a:defRPr>
-            </a:pPr>
-            <a:r>
-              <a:t>Matéria</a:t>
-            </a:r>
-          </a:p>
-        </p:txBody>
-      </p:sp>
-      <p:sp>
-        <p:nvSpPr>
-          <p:cNvPr id="32" name="TextBox 31"/>
-          <p:cNvSpPr txBox="1"/>
-          <p:nvPr/>
-        </p:nvSpPr>
-        <p:spPr>
-          <a:xfrm>
-            <a:off x="2926080" y="5212080"/>
-            <a:ext cx="3200400" cy="548640"/>
-          </a:xfrm>
-          <a:prstGeom prst="rect">
-            <a:avLst/>
-          </a:prstGeom>
-          <a:noFill/>
-        </p:spPr>
-        <p:txBody>
-          <a:bodyPr wrap="square">
-            <a:spAutoFit/>
-          </a:bodyPr>
-          <a:lstStyle/>
-          <a:p>
-            <a:pPr algn="l">
-              <a:defRPr sz="1600" b="1">
-                <a:solidFill>
-                  <a:srgbClr val="002B5C"/>
-                </a:solidFill>
-                <a:latin typeface="Segoe UI"/>
-              </a:defRPr>
-            </a:pPr>
-            <a:r>
-              <a:t>Desempenho Matéria</a:t>
-            </a:r>
-          </a:p>
-        </p:txBody>
-      </p:sp>
-      <p:sp>
-        <p:nvSpPr>
-          <p:cNvPr id="33" name="TextBox 32"/>
-          <p:cNvSpPr txBox="1"/>
-          <p:nvPr/>
-        </p:nvSpPr>
-        <p:spPr>
-          <a:xfrm>
-            <a:off x="6217920" y="5212080"/>
-            <a:ext cx="3657600" cy="548640"/>
-          </a:xfrm>
-          <a:prstGeom prst="rect">
-            <a:avLst/>
-          </a:prstGeom>
-          <a:noFill/>
-        </p:spPr>
-        <p:txBody>
-          <a:bodyPr wrap="square">
-            <a:spAutoFit/>
-          </a:bodyPr>
-          <a:lstStyle/>
-          <a:p>
-            <a:pPr algn="l">
-              <a:defRPr sz="1400" b="0">
-                <a:solidFill>
-                  <a:srgbClr val="666666"/>
-                </a:solidFill>
-                <a:latin typeface="Segoe UI"/>
-              </a:defRPr>
-            </a:pPr>
-            <a:r>
-              <a:t>Eficácia do currículo entre turmas</a:t>
-            </a:r>
-          </a:p>
-        </p:txBody>
-      </p:sp>
-      <p:sp>
-        <p:nvSpPr>
-          <p:cNvPr id="34" name="TextBox 33"/>
-          <p:cNvSpPr txBox="1"/>
-          <p:nvPr/>
-        </p:nvSpPr>
-        <p:spPr>
-          <a:xfrm>
-            <a:off x="10058400" y="5212080"/>
-            <a:ext cx="1828800" cy="548640"/>
-          </a:xfrm>
-          <a:prstGeom prst="rect">
-            <a:avLst/>
-          </a:prstGeom>
-          <a:noFill/>
-        </p:spPr>
-        <p:txBody>
-          <a:bodyPr wrap="square">
-            <a:spAutoFit/>
-          </a:bodyPr>
-          <a:lstStyle/>
-          <a:p>
-            <a:r>
-              <a:rPr sz="1100" u="sng">
-                <a:solidFill>
-                  <a:srgbClr val="4A90D9"/>
-                </a:solidFill>
-                <a:latin typeface="Segoe UI"/>
-                <a:hlinkClick r:id="rId7"/>
-              </a:rPr>
-              <a:t>📎 Abrir PDF</a:t>
-            </a:r>
-          </a:p>
-        </p:txBody>
-      </p:sp>
-      <p:sp>
-        <p:nvSpPr>
-          <p:cNvPr id="35" name="TextBox 34"/>
-          <p:cNvSpPr txBox="1"/>
-          <p:nvPr/>
-        </p:nvSpPr>
-        <p:spPr>
-          <a:xfrm>
-            <a:off x="731520" y="6035040"/>
-            <a:ext cx="10058400" cy="457200"/>
-          </a:xfrm>
-          <a:prstGeom prst="rect">
-            <a:avLst/>
-          </a:prstGeom>
-          <a:noFill/>
-        </p:spPr>
-        <p:txBody>
-          <a:bodyPr wrap="square">
-            <a:spAutoFit/>
-          </a:bodyPr>
-          <a:lstStyle/>
-          <a:p>
-            <a:pPr algn="ctr">
-              <a:defRPr sz="1600" b="1">
-                <a:solidFill>
-                  <a:srgbClr val="0056A0"/>
-                </a:solidFill>
-                <a:latin typeface="Segoe UI"/>
-              </a:defRPr>
-            </a:pPr>
-            <a:r>
-              <a:t>Tudo gerado automaticamente. O professor clica um botão e recebe narrativas pedagógicas reais.</a:t>
+              <a:t>→ Ver relatório completo: Desempenho Matéria (Matemática-V)</a:t>
             </a:r>
           </a:p>
         </p:txBody>
@@ -8716,6 +7915,1306 @@
 </file>
 
 <file path=ppt/slides/slide23.xml><?xml version="1.0" encoding="utf-8"?>
+<p:sld xmlns:a="http://schemas.openxmlformats.org/drawingml/2006/main" xmlns:p="http://schemas.openxmlformats.org/presentationml/2006/main" xmlns:r="http://schemas.openxmlformats.org/officeDocument/2006/relationships">
+  <p:cSld>
+    <p:bg>
+      <p:bgPr>
+        <a:solidFill>
+          <a:srgbClr val="FFFFFF"/>
+        </a:solidFill>
+        <a:effectLst/>
+      </p:bgPr>
+    </p:bg>
+    <p:spTree>
+      <p:nvGrpSpPr>
+        <p:cNvPr id="1" name=""/>
+        <p:cNvGrpSpPr/>
+        <p:nvPr/>
+      </p:nvGrpSpPr>
+      <p:grpSpPr/>
+      <p:sp>
+        <p:nvSpPr>
+          <p:cNvPr id="2" name="Rectangle 1"/>
+          <p:cNvSpPr/>
+          <p:nvPr/>
+        </p:nvSpPr>
+        <p:spPr>
+          <a:xfrm>
+            <a:off x="0" y="0"/>
+            <a:ext cx="12191695" cy="73152"/>
+          </a:xfrm>
+          <a:prstGeom prst="rect">
+            <a:avLst/>
+          </a:prstGeom>
+          <a:solidFill>
+            <a:srgbClr val="0056A0"/>
+          </a:solidFill>
+          <a:ln>
+            <a:noFill/>
+          </a:ln>
+        </p:spPr>
+        <p:style>
+          <a:lnRef idx="1">
+            <a:schemeClr val="accent1"/>
+          </a:lnRef>
+          <a:fillRef idx="3">
+            <a:schemeClr val="accent1"/>
+          </a:fillRef>
+          <a:effectRef idx="2">
+            <a:schemeClr val="accent1"/>
+          </a:effectRef>
+          <a:fontRef idx="minor">
+            <a:schemeClr val="lt1"/>
+          </a:fontRef>
+        </p:style>
+        <p:txBody>
+          <a:bodyPr rtlCol="0" anchor="ctr"/>
+          <a:lstStyle/>
+          <a:p>
+            <a:pPr algn="ctr"/>
+          </a:p>
+        </p:txBody>
+      </p:sp>
+      <p:sp>
+        <p:nvSpPr>
+          <p:cNvPr id="3" name="TextBox 2"/>
+          <p:cNvSpPr txBox="1"/>
+          <p:nvPr/>
+        </p:nvSpPr>
+        <p:spPr>
+          <a:xfrm>
+            <a:off x="731520" y="274320"/>
+            <a:ext cx="10058400" cy="731520"/>
+          </a:xfrm>
+          <a:prstGeom prst="rect">
+            <a:avLst/>
+          </a:prstGeom>
+          <a:noFill/>
+        </p:spPr>
+        <p:txBody>
+          <a:bodyPr wrap="square">
+            <a:spAutoFit/>
+          </a:bodyPr>
+          <a:lstStyle/>
+          <a:p>
+            <a:pPr algn="l">
+              <a:defRPr sz="3000" b="1">
+                <a:solidFill>
+                  <a:srgbClr val="002B5C"/>
+                </a:solidFill>
+                <a:latin typeface="Segoe UI"/>
+              </a:defRPr>
+            </a:pPr>
+            <a:r>
+              <a:t>Tudo Isso É Real</a:t>
+            </a:r>
+          </a:p>
+        </p:txBody>
+      </p:sp>
+      <p:sp>
+        <p:nvSpPr>
+          <p:cNvPr id="4" name="Rectangle 3"/>
+          <p:cNvSpPr/>
+          <p:nvPr/>
+        </p:nvSpPr>
+        <p:spPr>
+          <a:xfrm>
+            <a:off x="731520" y="960120"/>
+            <a:ext cx="2743200" cy="36576"/>
+          </a:xfrm>
+          <a:prstGeom prst="rect">
+            <a:avLst/>
+          </a:prstGeom>
+          <a:solidFill>
+            <a:srgbClr val="4A90D9"/>
+          </a:solidFill>
+          <a:ln>
+            <a:noFill/>
+          </a:ln>
+        </p:spPr>
+        <p:style>
+          <a:lnRef idx="1">
+            <a:schemeClr val="accent1"/>
+          </a:lnRef>
+          <a:fillRef idx="3">
+            <a:schemeClr val="accent1"/>
+          </a:fillRef>
+          <a:effectRef idx="2">
+            <a:schemeClr val="accent1"/>
+          </a:effectRef>
+          <a:fontRef idx="minor">
+            <a:schemeClr val="lt1"/>
+          </a:fontRef>
+        </p:style>
+        <p:txBody>
+          <a:bodyPr rtlCol="0" anchor="ctr"/>
+          <a:lstStyle/>
+          <a:p>
+            <a:pPr algn="ctr"/>
+          </a:p>
+        </p:txBody>
+      </p:sp>
+      <p:sp>
+        <p:nvSpPr>
+          <p:cNvPr id="5" name="Rectangle 4"/>
+          <p:cNvSpPr/>
+          <p:nvPr/>
+        </p:nvSpPr>
+        <p:spPr>
+          <a:xfrm>
+            <a:off x="731520" y="1280160"/>
+            <a:ext cx="2011680" cy="594360"/>
+          </a:xfrm>
+          <a:prstGeom prst="rect">
+            <a:avLst/>
+          </a:prstGeom>
+          <a:solidFill>
+            <a:srgbClr val="0056A0"/>
+          </a:solidFill>
+          <a:ln>
+            <a:noFill/>
+          </a:ln>
+        </p:spPr>
+        <p:style>
+          <a:lnRef idx="1">
+            <a:schemeClr val="accent1"/>
+          </a:lnRef>
+          <a:fillRef idx="3">
+            <a:schemeClr val="accent1"/>
+          </a:fillRef>
+          <a:effectRef idx="2">
+            <a:schemeClr val="accent1"/>
+          </a:effectRef>
+          <a:fontRef idx="minor">
+            <a:schemeClr val="lt1"/>
+          </a:fontRef>
+        </p:style>
+        <p:txBody>
+          <a:bodyPr rtlCol="0" anchor="ctr"/>
+          <a:lstStyle/>
+          <a:p>
+            <a:pPr algn="ctr"/>
+          </a:p>
+        </p:txBody>
+      </p:sp>
+      <p:sp>
+        <p:nvSpPr>
+          <p:cNvPr id="6" name="TextBox 5"/>
+          <p:cNvSpPr txBox="1"/>
+          <p:nvPr/>
+        </p:nvSpPr>
+        <p:spPr>
+          <a:xfrm>
+            <a:off x="731520" y="1389888"/>
+            <a:ext cx="2011680" cy="411480"/>
+          </a:xfrm>
+          <a:prstGeom prst="rect">
+            <a:avLst/>
+          </a:prstGeom>
+          <a:noFill/>
+        </p:spPr>
+        <p:txBody>
+          <a:bodyPr wrap="square">
+            <a:spAutoFit/>
+          </a:bodyPr>
+          <a:lstStyle/>
+          <a:p>
+            <a:pPr algn="ctr">
+              <a:defRPr sz="1400" b="1">
+                <a:solidFill>
+                  <a:srgbClr val="FFFFFF"/>
+                </a:solidFill>
+                <a:latin typeface="Segoe UI"/>
+              </a:defRPr>
+            </a:pPr>
+            <a:r>
+              <a:t>Questão</a:t>
+            </a:r>
+          </a:p>
+        </p:txBody>
+      </p:sp>
+      <p:sp>
+        <p:nvSpPr>
+          <p:cNvPr id="7" name="TextBox 6"/>
+          <p:cNvSpPr txBox="1"/>
+          <p:nvPr/>
+        </p:nvSpPr>
+        <p:spPr>
+          <a:xfrm>
+            <a:off x="2926080" y="1325880"/>
+            <a:ext cx="3200400" cy="548640"/>
+          </a:xfrm>
+          <a:prstGeom prst="rect">
+            <a:avLst/>
+          </a:prstGeom>
+          <a:noFill/>
+        </p:spPr>
+        <p:txBody>
+          <a:bodyPr wrap="square">
+            <a:spAutoFit/>
+          </a:bodyPr>
+          <a:lstStyle/>
+          <a:p>
+            <a:pPr algn="l">
+              <a:defRPr sz="1600" b="1">
+                <a:solidFill>
+                  <a:srgbClr val="002B5C"/>
+                </a:solidFill>
+                <a:latin typeface="Segoe UI"/>
+              </a:defRPr>
+            </a:pPr>
+            <a:r>
+              <a:t>Correção</a:t>
+            </a:r>
+          </a:p>
+        </p:txBody>
+      </p:sp>
+      <p:sp>
+        <p:nvSpPr>
+          <p:cNvPr id="8" name="TextBox 7"/>
+          <p:cNvSpPr txBox="1"/>
+          <p:nvPr/>
+        </p:nvSpPr>
+        <p:spPr>
+          <a:xfrm>
+            <a:off x="6217920" y="1325880"/>
+            <a:ext cx="3657600" cy="548640"/>
+          </a:xfrm>
+          <a:prstGeom prst="rect">
+            <a:avLst/>
+          </a:prstGeom>
+          <a:noFill/>
+        </p:spPr>
+        <p:txBody>
+          <a:bodyPr wrap="square">
+            <a:spAutoFit/>
+          </a:bodyPr>
+          <a:lstStyle/>
+          <a:p>
+            <a:pPr algn="l">
+              <a:defRPr sz="1400" b="0">
+                <a:solidFill>
+                  <a:srgbClr val="666666"/>
+                </a:solidFill>
+                <a:latin typeface="Segoe UI"/>
+              </a:defRPr>
+            </a:pPr>
+            <a:r>
+              <a:t>Raciocínio, tipo de erro, potencial</a:t>
+            </a:r>
+          </a:p>
+        </p:txBody>
+      </p:sp>
+      <p:sp>
+        <p:nvSpPr>
+          <p:cNvPr id="9" name="TextBox 8"/>
+          <p:cNvSpPr txBox="1"/>
+          <p:nvPr/>
+        </p:nvSpPr>
+        <p:spPr>
+          <a:xfrm>
+            <a:off x="10058400" y="1325880"/>
+            <a:ext cx="1828800" cy="548640"/>
+          </a:xfrm>
+          <a:prstGeom prst="rect">
+            <a:avLst/>
+          </a:prstGeom>
+          <a:noFill/>
+        </p:spPr>
+        <p:txBody>
+          <a:bodyPr wrap="square">
+            <a:spAutoFit/>
+          </a:bodyPr>
+          <a:lstStyle/>
+          <a:p>
+            <a:r>
+              <a:rPr sz="1100" u="sng">
+                <a:solidFill>
+                  <a:srgbClr val="4A90D9"/>
+                </a:solidFill>
+                <a:latin typeface="Segoe UI"/>
+                <a:hlinkClick r:id="rId2"/>
+              </a:rPr>
+              <a:t>📎 Abrir PDF</a:t>
+            </a:r>
+          </a:p>
+        </p:txBody>
+      </p:sp>
+      <p:sp>
+        <p:nvSpPr>
+          <p:cNvPr id="10" name="Rectangle 9"/>
+          <p:cNvSpPr/>
+          <p:nvPr/>
+        </p:nvSpPr>
+        <p:spPr>
+          <a:xfrm>
+            <a:off x="731520" y="2057400"/>
+            <a:ext cx="2011680" cy="594360"/>
+          </a:xfrm>
+          <a:prstGeom prst="rect">
+            <a:avLst/>
+          </a:prstGeom>
+          <a:solidFill>
+            <a:srgbClr val="0056A0"/>
+          </a:solidFill>
+          <a:ln>
+            <a:noFill/>
+          </a:ln>
+        </p:spPr>
+        <p:style>
+          <a:lnRef idx="1">
+            <a:schemeClr val="accent1"/>
+          </a:lnRef>
+          <a:fillRef idx="3">
+            <a:schemeClr val="accent1"/>
+          </a:fillRef>
+          <a:effectRef idx="2">
+            <a:schemeClr val="accent1"/>
+          </a:effectRef>
+          <a:fontRef idx="minor">
+            <a:schemeClr val="lt1"/>
+          </a:fontRef>
+        </p:style>
+        <p:txBody>
+          <a:bodyPr rtlCol="0" anchor="ctr"/>
+          <a:lstStyle/>
+          <a:p>
+            <a:pPr algn="ctr"/>
+          </a:p>
+        </p:txBody>
+      </p:sp>
+      <p:sp>
+        <p:nvSpPr>
+          <p:cNvPr id="11" name="TextBox 10"/>
+          <p:cNvSpPr txBox="1"/>
+          <p:nvPr/>
+        </p:nvSpPr>
+        <p:spPr>
+          <a:xfrm>
+            <a:off x="731520" y="2167128"/>
+            <a:ext cx="2011680" cy="411480"/>
+          </a:xfrm>
+          <a:prstGeom prst="rect">
+            <a:avLst/>
+          </a:prstGeom>
+          <a:noFill/>
+        </p:spPr>
+        <p:txBody>
+          <a:bodyPr wrap="square">
+            <a:spAutoFit/>
+          </a:bodyPr>
+          <a:lstStyle/>
+          <a:p>
+            <a:pPr algn="ctr">
+              <a:defRPr sz="1400" b="1">
+                <a:solidFill>
+                  <a:srgbClr val="FFFFFF"/>
+                </a:solidFill>
+                <a:latin typeface="Segoe UI"/>
+              </a:defRPr>
+            </a:pPr>
+            <a:r>
+              <a:t>Aluno</a:t>
+            </a:r>
+          </a:p>
+        </p:txBody>
+      </p:sp>
+      <p:sp>
+        <p:nvSpPr>
+          <p:cNvPr id="12" name="TextBox 11"/>
+          <p:cNvSpPr txBox="1"/>
+          <p:nvPr/>
+        </p:nvSpPr>
+        <p:spPr>
+          <a:xfrm>
+            <a:off x="2926080" y="2103120"/>
+            <a:ext cx="3200400" cy="548640"/>
+          </a:xfrm>
+          <a:prstGeom prst="rect">
+            <a:avLst/>
+          </a:prstGeom>
+          <a:noFill/>
+        </p:spPr>
+        <p:txBody>
+          <a:bodyPr wrap="square">
+            <a:spAutoFit/>
+          </a:bodyPr>
+          <a:lstStyle/>
+          <a:p>
+            <a:pPr algn="l">
+              <a:defRPr sz="1600" b="1">
+                <a:solidFill>
+                  <a:srgbClr val="002B5C"/>
+                </a:solidFill>
+                <a:latin typeface="Segoe UI"/>
+              </a:defRPr>
+            </a:pPr>
+            <a:r>
+              <a:t>Análise de Habilidades</a:t>
+            </a:r>
+          </a:p>
+        </p:txBody>
+      </p:sp>
+      <p:sp>
+        <p:nvSpPr>
+          <p:cNvPr id="13" name="TextBox 12"/>
+          <p:cNvSpPr txBox="1"/>
+          <p:nvPr/>
+        </p:nvSpPr>
+        <p:spPr>
+          <a:xfrm>
+            <a:off x="6217920" y="2103120"/>
+            <a:ext cx="3657600" cy="548640"/>
+          </a:xfrm>
+          <a:prstGeom prst="rect">
+            <a:avLst/>
+          </a:prstGeom>
+          <a:noFill/>
+        </p:spPr>
+        <p:txBody>
+          <a:bodyPr wrap="square">
+            <a:spAutoFit/>
+          </a:bodyPr>
+          <a:lstStyle/>
+          <a:p>
+            <a:pPr algn="l">
+              <a:defRPr sz="1400" b="0">
+                <a:solidFill>
+                  <a:srgbClr val="666666"/>
+                </a:solidFill>
+                <a:latin typeface="Segoe UI"/>
+              </a:defRPr>
+            </a:pPr>
+            <a:r>
+              <a:t>Perfil cognitivo, padrões, recomendações</a:t>
+            </a:r>
+          </a:p>
+        </p:txBody>
+      </p:sp>
+      <p:sp>
+        <p:nvSpPr>
+          <p:cNvPr id="14" name="TextBox 13"/>
+          <p:cNvSpPr txBox="1"/>
+          <p:nvPr/>
+        </p:nvSpPr>
+        <p:spPr>
+          <a:xfrm>
+            <a:off x="10058400" y="2103120"/>
+            <a:ext cx="1828800" cy="548640"/>
+          </a:xfrm>
+          <a:prstGeom prst="rect">
+            <a:avLst/>
+          </a:prstGeom>
+          <a:noFill/>
+        </p:spPr>
+        <p:txBody>
+          <a:bodyPr wrap="square">
+            <a:spAutoFit/>
+          </a:bodyPr>
+          <a:lstStyle/>
+          <a:p>
+            <a:r>
+              <a:rPr sz="1100" u="sng">
+                <a:solidFill>
+                  <a:srgbClr val="4A90D9"/>
+                </a:solidFill>
+                <a:latin typeface="Segoe UI"/>
+                <a:hlinkClick r:id="rId3"/>
+              </a:rPr>
+              <a:t>📎 Abrir PDF</a:t>
+            </a:r>
+          </a:p>
+        </p:txBody>
+      </p:sp>
+      <p:sp>
+        <p:nvSpPr>
+          <p:cNvPr id="15" name="Rectangle 14"/>
+          <p:cNvSpPr/>
+          <p:nvPr/>
+        </p:nvSpPr>
+        <p:spPr>
+          <a:xfrm>
+            <a:off x="731520" y="2834640"/>
+            <a:ext cx="2011680" cy="594360"/>
+          </a:xfrm>
+          <a:prstGeom prst="rect">
+            <a:avLst/>
+          </a:prstGeom>
+          <a:solidFill>
+            <a:srgbClr val="0056A0"/>
+          </a:solidFill>
+          <a:ln>
+            <a:noFill/>
+          </a:ln>
+        </p:spPr>
+        <p:style>
+          <a:lnRef idx="1">
+            <a:schemeClr val="accent1"/>
+          </a:lnRef>
+          <a:fillRef idx="3">
+            <a:schemeClr val="accent1"/>
+          </a:fillRef>
+          <a:effectRef idx="2">
+            <a:schemeClr val="accent1"/>
+          </a:effectRef>
+          <a:fontRef idx="minor">
+            <a:schemeClr val="lt1"/>
+          </a:fontRef>
+        </p:style>
+        <p:txBody>
+          <a:bodyPr rtlCol="0" anchor="ctr"/>
+          <a:lstStyle/>
+          <a:p>
+            <a:pPr algn="ctr"/>
+          </a:p>
+        </p:txBody>
+      </p:sp>
+      <p:sp>
+        <p:nvSpPr>
+          <p:cNvPr id="16" name="TextBox 15"/>
+          <p:cNvSpPr txBox="1"/>
+          <p:nvPr/>
+        </p:nvSpPr>
+        <p:spPr>
+          <a:xfrm>
+            <a:off x="731520" y="2944368"/>
+            <a:ext cx="2011680" cy="411480"/>
+          </a:xfrm>
+          <a:prstGeom prst="rect">
+            <a:avLst/>
+          </a:prstGeom>
+          <a:noFill/>
+        </p:spPr>
+        <p:txBody>
+          <a:bodyPr wrap="square">
+            <a:spAutoFit/>
+          </a:bodyPr>
+          <a:lstStyle/>
+          <a:p>
+            <a:pPr algn="ctr">
+              <a:defRPr sz="1400" b="1">
+                <a:solidFill>
+                  <a:srgbClr val="FFFFFF"/>
+                </a:solidFill>
+                <a:latin typeface="Segoe UI"/>
+              </a:defRPr>
+            </a:pPr>
+            <a:r>
+              <a:t>Aluno</a:t>
+            </a:r>
+          </a:p>
+        </p:txBody>
+      </p:sp>
+      <p:sp>
+        <p:nvSpPr>
+          <p:cNvPr id="17" name="TextBox 16"/>
+          <p:cNvSpPr txBox="1"/>
+          <p:nvPr/>
+        </p:nvSpPr>
+        <p:spPr>
+          <a:xfrm>
+            <a:off x="2926080" y="2880360"/>
+            <a:ext cx="3200400" cy="548640"/>
+          </a:xfrm>
+          <a:prstGeom prst="rect">
+            <a:avLst/>
+          </a:prstGeom>
+          <a:noFill/>
+        </p:spPr>
+        <p:txBody>
+          <a:bodyPr wrap="square">
+            <a:spAutoFit/>
+          </a:bodyPr>
+          <a:lstStyle/>
+          <a:p>
+            <a:pPr algn="l">
+              <a:defRPr sz="1600" b="1">
+                <a:solidFill>
+                  <a:srgbClr val="002B5C"/>
+                </a:solidFill>
+                <a:latin typeface="Segoe UI"/>
+              </a:defRPr>
+            </a:pPr>
+            <a:r>
+              <a:t>Relatório Final</a:t>
+            </a:r>
+          </a:p>
+        </p:txBody>
+      </p:sp>
+      <p:sp>
+        <p:nvSpPr>
+          <p:cNvPr id="18" name="TextBox 17"/>
+          <p:cNvSpPr txBox="1"/>
+          <p:nvPr/>
+        </p:nvSpPr>
+        <p:spPr>
+          <a:xfrm>
+            <a:off x="6217920" y="2880360"/>
+            <a:ext cx="3657600" cy="548640"/>
+          </a:xfrm>
+          <a:prstGeom prst="rect">
+            <a:avLst/>
+          </a:prstGeom>
+          <a:noFill/>
+        </p:spPr>
+        <p:txBody>
+          <a:bodyPr wrap="square">
+            <a:spAutoFit/>
+          </a:bodyPr>
+          <a:lstStyle/>
+          <a:p>
+            <a:pPr algn="l">
+              <a:defRPr sz="1400" b="0">
+                <a:solidFill>
+                  <a:srgbClr val="666666"/>
+                </a:solidFill>
+                <a:latin typeface="Segoe UI"/>
+              </a:defRPr>
+            </a:pPr>
+            <a:r>
+              <a:t>Narrativa completa para aluno e pais</a:t>
+            </a:r>
+          </a:p>
+        </p:txBody>
+      </p:sp>
+      <p:sp>
+        <p:nvSpPr>
+          <p:cNvPr id="19" name="TextBox 18"/>
+          <p:cNvSpPr txBox="1"/>
+          <p:nvPr/>
+        </p:nvSpPr>
+        <p:spPr>
+          <a:xfrm>
+            <a:off x="10058400" y="2880360"/>
+            <a:ext cx="1828800" cy="548640"/>
+          </a:xfrm>
+          <a:prstGeom prst="rect">
+            <a:avLst/>
+          </a:prstGeom>
+          <a:noFill/>
+        </p:spPr>
+        <p:txBody>
+          <a:bodyPr wrap="square">
+            <a:spAutoFit/>
+          </a:bodyPr>
+          <a:lstStyle/>
+          <a:p>
+            <a:r>
+              <a:rPr sz="1100" u="sng">
+                <a:solidFill>
+                  <a:srgbClr val="4A90D9"/>
+                </a:solidFill>
+                <a:latin typeface="Segoe UI"/>
+                <a:hlinkClick r:id="rId4"/>
+              </a:rPr>
+              <a:t>📎 Abrir PDF</a:t>
+            </a:r>
+          </a:p>
+        </p:txBody>
+      </p:sp>
+      <p:sp>
+        <p:nvSpPr>
+          <p:cNvPr id="20" name="Rectangle 19"/>
+          <p:cNvSpPr/>
+          <p:nvPr/>
+        </p:nvSpPr>
+        <p:spPr>
+          <a:xfrm>
+            <a:off x="731520" y="3611880"/>
+            <a:ext cx="2011680" cy="594360"/>
+          </a:xfrm>
+          <a:prstGeom prst="rect">
+            <a:avLst/>
+          </a:prstGeom>
+          <a:solidFill>
+            <a:srgbClr val="002B5C"/>
+          </a:solidFill>
+          <a:ln>
+            <a:noFill/>
+          </a:ln>
+        </p:spPr>
+        <p:style>
+          <a:lnRef idx="1">
+            <a:schemeClr val="accent1"/>
+          </a:lnRef>
+          <a:fillRef idx="3">
+            <a:schemeClr val="accent1"/>
+          </a:fillRef>
+          <a:effectRef idx="2">
+            <a:schemeClr val="accent1"/>
+          </a:effectRef>
+          <a:fontRef idx="minor">
+            <a:schemeClr val="lt1"/>
+          </a:fontRef>
+        </p:style>
+        <p:txBody>
+          <a:bodyPr rtlCol="0" anchor="ctr"/>
+          <a:lstStyle/>
+          <a:p>
+            <a:pPr algn="ctr"/>
+          </a:p>
+        </p:txBody>
+      </p:sp>
+      <p:sp>
+        <p:nvSpPr>
+          <p:cNvPr id="21" name="TextBox 20"/>
+          <p:cNvSpPr txBox="1"/>
+          <p:nvPr/>
+        </p:nvSpPr>
+        <p:spPr>
+          <a:xfrm>
+            <a:off x="731520" y="3721608"/>
+            <a:ext cx="2011680" cy="411480"/>
+          </a:xfrm>
+          <a:prstGeom prst="rect">
+            <a:avLst/>
+          </a:prstGeom>
+          <a:noFill/>
+        </p:spPr>
+        <p:txBody>
+          <a:bodyPr wrap="square">
+            <a:spAutoFit/>
+          </a:bodyPr>
+          <a:lstStyle/>
+          <a:p>
+            <a:pPr algn="ctr">
+              <a:defRPr sz="1400" b="1">
+                <a:solidFill>
+                  <a:srgbClr val="FFFFFF"/>
+                </a:solidFill>
+                <a:latin typeface="Segoe UI"/>
+              </a:defRPr>
+            </a:pPr>
+            <a:r>
+              <a:t>Turma × Atividade</a:t>
+            </a:r>
+          </a:p>
+        </p:txBody>
+      </p:sp>
+      <p:sp>
+        <p:nvSpPr>
+          <p:cNvPr id="22" name="TextBox 21"/>
+          <p:cNvSpPr txBox="1"/>
+          <p:nvPr/>
+        </p:nvSpPr>
+        <p:spPr>
+          <a:xfrm>
+            <a:off x="2926080" y="3657600"/>
+            <a:ext cx="3200400" cy="548640"/>
+          </a:xfrm>
+          <a:prstGeom prst="rect">
+            <a:avLst/>
+          </a:prstGeom>
+          <a:noFill/>
+        </p:spPr>
+        <p:txBody>
+          <a:bodyPr wrap="square">
+            <a:spAutoFit/>
+          </a:bodyPr>
+          <a:lstStyle/>
+          <a:p>
+            <a:pPr algn="l">
+              <a:defRPr sz="1600" b="1">
+                <a:solidFill>
+                  <a:srgbClr val="002B5C"/>
+                </a:solidFill>
+                <a:latin typeface="Segoe UI"/>
+              </a:defRPr>
+            </a:pPr>
+            <a:r>
+              <a:t>Desempenho Tarefa</a:t>
+            </a:r>
+          </a:p>
+        </p:txBody>
+      </p:sp>
+      <p:sp>
+        <p:nvSpPr>
+          <p:cNvPr id="23" name="TextBox 22"/>
+          <p:cNvSpPr txBox="1"/>
+          <p:nvPr/>
+        </p:nvSpPr>
+        <p:spPr>
+          <a:xfrm>
+            <a:off x="6217920" y="3657600"/>
+            <a:ext cx="3657600" cy="548640"/>
+          </a:xfrm>
+          <a:prstGeom prst="rect">
+            <a:avLst/>
+          </a:prstGeom>
+          <a:noFill/>
+        </p:spPr>
+        <p:txBody>
+          <a:bodyPr wrap="square">
+            <a:spAutoFit/>
+          </a:bodyPr>
+          <a:lstStyle/>
+          <a:p>
+            <a:pPr algn="l">
+              <a:defRPr sz="1400" b="0">
+                <a:solidFill>
+                  <a:srgbClr val="666666"/>
+                </a:solidFill>
+                <a:latin typeface="Segoe UI"/>
+              </a:defRPr>
+            </a:pPr>
+            <a:r>
+              <a:t>Padrões coletivos, exemplos específicos</a:t>
+            </a:r>
+          </a:p>
+        </p:txBody>
+      </p:sp>
+      <p:sp>
+        <p:nvSpPr>
+          <p:cNvPr id="24" name="TextBox 23"/>
+          <p:cNvSpPr txBox="1"/>
+          <p:nvPr/>
+        </p:nvSpPr>
+        <p:spPr>
+          <a:xfrm>
+            <a:off x="10058400" y="3657600"/>
+            <a:ext cx="1828800" cy="548640"/>
+          </a:xfrm>
+          <a:prstGeom prst="rect">
+            <a:avLst/>
+          </a:prstGeom>
+          <a:noFill/>
+        </p:spPr>
+        <p:txBody>
+          <a:bodyPr wrap="square">
+            <a:spAutoFit/>
+          </a:bodyPr>
+          <a:lstStyle/>
+          <a:p>
+            <a:r>
+              <a:rPr sz="1100" u="sng">
+                <a:solidFill>
+                  <a:srgbClr val="4A90D9"/>
+                </a:solidFill>
+                <a:latin typeface="Segoe UI"/>
+                <a:hlinkClick r:id="rId5"/>
+              </a:rPr>
+              <a:t>📎 Abrir PDF</a:t>
+            </a:r>
+          </a:p>
+        </p:txBody>
+      </p:sp>
+      <p:sp>
+        <p:nvSpPr>
+          <p:cNvPr id="25" name="Rectangle 24"/>
+          <p:cNvSpPr/>
+          <p:nvPr/>
+        </p:nvSpPr>
+        <p:spPr>
+          <a:xfrm>
+            <a:off x="731520" y="4389120"/>
+            <a:ext cx="2011680" cy="594360"/>
+          </a:xfrm>
+          <a:prstGeom prst="rect">
+            <a:avLst/>
+          </a:prstGeom>
+          <a:solidFill>
+            <a:srgbClr val="002B5C"/>
+          </a:solidFill>
+          <a:ln>
+            <a:noFill/>
+          </a:ln>
+        </p:spPr>
+        <p:style>
+          <a:lnRef idx="1">
+            <a:schemeClr val="accent1"/>
+          </a:lnRef>
+          <a:fillRef idx="3">
+            <a:schemeClr val="accent1"/>
+          </a:fillRef>
+          <a:effectRef idx="2">
+            <a:schemeClr val="accent1"/>
+          </a:effectRef>
+          <a:fontRef idx="minor">
+            <a:schemeClr val="lt1"/>
+          </a:fontRef>
+        </p:style>
+        <p:txBody>
+          <a:bodyPr rtlCol="0" anchor="ctr"/>
+          <a:lstStyle/>
+          <a:p>
+            <a:pPr algn="ctr"/>
+          </a:p>
+        </p:txBody>
+      </p:sp>
+      <p:sp>
+        <p:nvSpPr>
+          <p:cNvPr id="26" name="TextBox 25"/>
+          <p:cNvSpPr txBox="1"/>
+          <p:nvPr/>
+        </p:nvSpPr>
+        <p:spPr>
+          <a:xfrm>
+            <a:off x="731520" y="4498848"/>
+            <a:ext cx="2011680" cy="411480"/>
+          </a:xfrm>
+          <a:prstGeom prst="rect">
+            <a:avLst/>
+          </a:prstGeom>
+          <a:noFill/>
+        </p:spPr>
+        <p:txBody>
+          <a:bodyPr wrap="square">
+            <a:spAutoFit/>
+          </a:bodyPr>
+          <a:lstStyle/>
+          <a:p>
+            <a:pPr algn="ctr">
+              <a:defRPr sz="1400" b="1">
+                <a:solidFill>
+                  <a:srgbClr val="FFFFFF"/>
+                </a:solidFill>
+                <a:latin typeface="Segoe UI"/>
+              </a:defRPr>
+            </a:pPr>
+            <a:r>
+              <a:t>Turma</a:t>
+            </a:r>
+          </a:p>
+        </p:txBody>
+      </p:sp>
+      <p:sp>
+        <p:nvSpPr>
+          <p:cNvPr id="27" name="TextBox 26"/>
+          <p:cNvSpPr txBox="1"/>
+          <p:nvPr/>
+        </p:nvSpPr>
+        <p:spPr>
+          <a:xfrm>
+            <a:off x="2926080" y="4434840"/>
+            <a:ext cx="3200400" cy="548640"/>
+          </a:xfrm>
+          <a:prstGeom prst="rect">
+            <a:avLst/>
+          </a:prstGeom>
+          <a:noFill/>
+        </p:spPr>
+        <p:txBody>
+          <a:bodyPr wrap="square">
+            <a:spAutoFit/>
+          </a:bodyPr>
+          <a:lstStyle/>
+          <a:p>
+            <a:pPr algn="l">
+              <a:defRPr sz="1600" b="1">
+                <a:solidFill>
+                  <a:srgbClr val="002B5C"/>
+                </a:solidFill>
+                <a:latin typeface="Segoe UI"/>
+              </a:defRPr>
+            </a:pPr>
+            <a:r>
+              <a:t>Desempenho Turma</a:t>
+            </a:r>
+          </a:p>
+        </p:txBody>
+      </p:sp>
+      <p:sp>
+        <p:nvSpPr>
+          <p:cNvPr id="28" name="TextBox 27"/>
+          <p:cNvSpPr txBox="1"/>
+          <p:nvPr/>
+        </p:nvSpPr>
+        <p:spPr>
+          <a:xfrm>
+            <a:off x="6217920" y="4434840"/>
+            <a:ext cx="3657600" cy="548640"/>
+          </a:xfrm>
+          <a:prstGeom prst="rect">
+            <a:avLst/>
+          </a:prstGeom>
+          <a:noFill/>
+        </p:spPr>
+        <p:txBody>
+          <a:bodyPr wrap="square">
+            <a:spAutoFit/>
+          </a:bodyPr>
+          <a:lstStyle/>
+          <a:p>
+            <a:pPr algn="l">
+              <a:defRPr sz="1400" b="0">
+                <a:solidFill>
+                  <a:srgbClr val="666666"/>
+                </a:solidFill>
+                <a:latin typeface="Segoe UI"/>
+              </a:defRPr>
+            </a:pPr>
+            <a:r>
+              <a:t>Evolução ao longo do tempo</a:t>
+            </a:r>
+          </a:p>
+        </p:txBody>
+      </p:sp>
+      <p:sp>
+        <p:nvSpPr>
+          <p:cNvPr id="29" name="TextBox 28"/>
+          <p:cNvSpPr txBox="1"/>
+          <p:nvPr/>
+        </p:nvSpPr>
+        <p:spPr>
+          <a:xfrm>
+            <a:off x="10058400" y="4434840"/>
+            <a:ext cx="1828800" cy="548640"/>
+          </a:xfrm>
+          <a:prstGeom prst="rect">
+            <a:avLst/>
+          </a:prstGeom>
+          <a:noFill/>
+        </p:spPr>
+        <p:txBody>
+          <a:bodyPr wrap="square">
+            <a:spAutoFit/>
+          </a:bodyPr>
+          <a:lstStyle/>
+          <a:p>
+            <a:r>
+              <a:rPr sz="1100" u="sng">
+                <a:solidFill>
+                  <a:srgbClr val="4A90D9"/>
+                </a:solidFill>
+                <a:latin typeface="Segoe UI"/>
+                <a:hlinkClick r:id="rId6"/>
+              </a:rPr>
+              <a:t>📎 Abrir PDF</a:t>
+            </a:r>
+          </a:p>
+        </p:txBody>
+      </p:sp>
+      <p:sp>
+        <p:nvSpPr>
+          <p:cNvPr id="30" name="Rectangle 29"/>
+          <p:cNvSpPr/>
+          <p:nvPr/>
+        </p:nvSpPr>
+        <p:spPr>
+          <a:xfrm>
+            <a:off x="731520" y="5166360"/>
+            <a:ext cx="2011680" cy="594360"/>
+          </a:xfrm>
+          <a:prstGeom prst="rect">
+            <a:avLst/>
+          </a:prstGeom>
+          <a:solidFill>
+            <a:srgbClr val="002B5C"/>
+          </a:solidFill>
+          <a:ln>
+            <a:noFill/>
+          </a:ln>
+        </p:spPr>
+        <p:style>
+          <a:lnRef idx="1">
+            <a:schemeClr val="accent1"/>
+          </a:lnRef>
+          <a:fillRef idx="3">
+            <a:schemeClr val="accent1"/>
+          </a:fillRef>
+          <a:effectRef idx="2">
+            <a:schemeClr val="accent1"/>
+          </a:effectRef>
+          <a:fontRef idx="minor">
+            <a:schemeClr val="lt1"/>
+          </a:fontRef>
+        </p:style>
+        <p:txBody>
+          <a:bodyPr rtlCol="0" anchor="ctr"/>
+          <a:lstStyle/>
+          <a:p>
+            <a:pPr algn="ctr"/>
+          </a:p>
+        </p:txBody>
+      </p:sp>
+      <p:sp>
+        <p:nvSpPr>
+          <p:cNvPr id="31" name="TextBox 30"/>
+          <p:cNvSpPr txBox="1"/>
+          <p:nvPr/>
+        </p:nvSpPr>
+        <p:spPr>
+          <a:xfrm>
+            <a:off x="731520" y="5276088"/>
+            <a:ext cx="2011680" cy="411480"/>
+          </a:xfrm>
+          <a:prstGeom prst="rect">
+            <a:avLst/>
+          </a:prstGeom>
+          <a:noFill/>
+        </p:spPr>
+        <p:txBody>
+          <a:bodyPr wrap="square">
+            <a:spAutoFit/>
+          </a:bodyPr>
+          <a:lstStyle/>
+          <a:p>
+            <a:pPr algn="ctr">
+              <a:defRPr sz="1400" b="1">
+                <a:solidFill>
+                  <a:srgbClr val="FFFFFF"/>
+                </a:solidFill>
+                <a:latin typeface="Segoe UI"/>
+              </a:defRPr>
+            </a:pPr>
+            <a:r>
+              <a:t>Matéria</a:t>
+            </a:r>
+          </a:p>
+        </p:txBody>
+      </p:sp>
+      <p:sp>
+        <p:nvSpPr>
+          <p:cNvPr id="32" name="TextBox 31"/>
+          <p:cNvSpPr txBox="1"/>
+          <p:nvPr/>
+        </p:nvSpPr>
+        <p:spPr>
+          <a:xfrm>
+            <a:off x="2926080" y="5212080"/>
+            <a:ext cx="3200400" cy="548640"/>
+          </a:xfrm>
+          <a:prstGeom prst="rect">
+            <a:avLst/>
+          </a:prstGeom>
+          <a:noFill/>
+        </p:spPr>
+        <p:txBody>
+          <a:bodyPr wrap="square">
+            <a:spAutoFit/>
+          </a:bodyPr>
+          <a:lstStyle/>
+          <a:p>
+            <a:pPr algn="l">
+              <a:defRPr sz="1600" b="1">
+                <a:solidFill>
+                  <a:srgbClr val="002B5C"/>
+                </a:solidFill>
+                <a:latin typeface="Segoe UI"/>
+              </a:defRPr>
+            </a:pPr>
+            <a:r>
+              <a:t>Desempenho Matéria</a:t>
+            </a:r>
+          </a:p>
+        </p:txBody>
+      </p:sp>
+      <p:sp>
+        <p:nvSpPr>
+          <p:cNvPr id="33" name="TextBox 32"/>
+          <p:cNvSpPr txBox="1"/>
+          <p:nvPr/>
+        </p:nvSpPr>
+        <p:spPr>
+          <a:xfrm>
+            <a:off x="6217920" y="5212080"/>
+            <a:ext cx="3657600" cy="548640"/>
+          </a:xfrm>
+          <a:prstGeom prst="rect">
+            <a:avLst/>
+          </a:prstGeom>
+          <a:noFill/>
+        </p:spPr>
+        <p:txBody>
+          <a:bodyPr wrap="square">
+            <a:spAutoFit/>
+          </a:bodyPr>
+          <a:lstStyle/>
+          <a:p>
+            <a:pPr algn="l">
+              <a:defRPr sz="1400" b="0">
+                <a:solidFill>
+                  <a:srgbClr val="666666"/>
+                </a:solidFill>
+                <a:latin typeface="Segoe UI"/>
+              </a:defRPr>
+            </a:pPr>
+            <a:r>
+              <a:t>Eficácia do currículo entre turmas</a:t>
+            </a:r>
+          </a:p>
+        </p:txBody>
+      </p:sp>
+      <p:sp>
+        <p:nvSpPr>
+          <p:cNvPr id="34" name="TextBox 33"/>
+          <p:cNvSpPr txBox="1"/>
+          <p:nvPr/>
+        </p:nvSpPr>
+        <p:spPr>
+          <a:xfrm>
+            <a:off x="10058400" y="5212080"/>
+            <a:ext cx="1828800" cy="548640"/>
+          </a:xfrm>
+          <a:prstGeom prst="rect">
+            <a:avLst/>
+          </a:prstGeom>
+          <a:noFill/>
+        </p:spPr>
+        <p:txBody>
+          <a:bodyPr wrap="square">
+            <a:spAutoFit/>
+          </a:bodyPr>
+          <a:lstStyle/>
+          <a:p>
+            <a:r>
+              <a:rPr sz="1100" u="sng">
+                <a:solidFill>
+                  <a:srgbClr val="4A90D9"/>
+                </a:solidFill>
+                <a:latin typeface="Segoe UI"/>
+                <a:hlinkClick r:id="rId7"/>
+              </a:rPr>
+              <a:t>📎 Abrir PDF</a:t>
+            </a:r>
+          </a:p>
+        </p:txBody>
+      </p:sp>
+      <p:sp>
+        <p:nvSpPr>
+          <p:cNvPr id="35" name="TextBox 34"/>
+          <p:cNvSpPr txBox="1"/>
+          <p:nvPr/>
+        </p:nvSpPr>
+        <p:spPr>
+          <a:xfrm>
+            <a:off x="731520" y="6035040"/>
+            <a:ext cx="10058400" cy="457200"/>
+          </a:xfrm>
+          <a:prstGeom prst="rect">
+            <a:avLst/>
+          </a:prstGeom>
+          <a:noFill/>
+        </p:spPr>
+        <p:txBody>
+          <a:bodyPr wrap="square">
+            <a:spAutoFit/>
+          </a:bodyPr>
+          <a:lstStyle/>
+          <a:p>
+            <a:pPr algn="ctr">
+              <a:defRPr sz="1600" b="1">
+                <a:solidFill>
+                  <a:srgbClr val="0056A0"/>
+                </a:solidFill>
+                <a:latin typeface="Segoe UI"/>
+              </a:defRPr>
+            </a:pPr>
+            <a:r>
+              <a:t>Tudo gerado automaticamente. O professor clica um botão e recebe narrativas pedagógicas reais.</a:t>
+            </a:r>
+          </a:p>
+        </p:txBody>
+      </p:sp>
+    </p:spTree>
+  </p:cSld>
+  <p:clrMapOvr>
+    <a:masterClrMapping/>
+  </p:clrMapOvr>
+</p:sld>
+</file>
+
+<file path=ppt/slides/slide24.xml><?xml version="1.0" encoding="utf-8"?>
 <p:sld xmlns:a="http://schemas.openxmlformats.org/drawingml/2006/main" xmlns:p="http://schemas.openxmlformats.org/presentationml/2006/main" xmlns:r="http://schemas.openxmlformats.org/officeDocument/2006/relationships">
   <p:cSld>
     <p:bg>
@@ -9060,7 +9559,7 @@
 </p:sld>
 </file>
 
-<file path=ppt/slides/slide24.xml><?xml version="1.0" encoding="utf-8"?>
+<file path=ppt/slides/slide25.xml><?xml version="1.0" encoding="utf-8"?>
 <p:sld xmlns:a="http://schemas.openxmlformats.org/drawingml/2006/main" xmlns:p="http://schemas.openxmlformats.org/presentationml/2006/main" xmlns:r="http://schemas.openxmlformats.org/officeDocument/2006/relationships">
   <p:cSld>
     <p:bg>

</xml_diff>